<commit_message>
Replace research paper slide with 'Why AI?' slide, add 4 more example claims, update PPTX
</commit_message>
<xml_diff>
--- a/MedCheck_ACP_2026.pptx
+++ b/MedCheck_ACP_2026.pptx
@@ -8139,7 +8139,7 @@
             <a:avLst/>
           </a:prstGeom>
           <a:solidFill>
-            <a:srgbClr val="7916F6"/>
+            <a:srgbClr val="2663EB"/>
           </a:solidFill>
           <a:ln>
             <a:noFill/>
@@ -8191,32 +8191,66 @@
           <a:p>
             <a:pPr algn="l"/>
             <a:r>
-              <a:rPr sz="2800" b="1">
+              <a:rPr sz="3000" b="1">
                 <a:solidFill>
                   <a:srgbClr val="FFFFFF"/>
                 </a:solidFill>
               </a:rPr>
-              <a:t>🔭  This Is More Than an App — The Research Layer</a:t>
-            </a:r>
-          </a:p>
-        </p:txBody>
-      </p:sp>
-      <p:sp>
-        <p:nvSpPr>
-          <p:cNvPr id="5" name="Rectangle 4"/>
+              <a:t>🤖  Why AI Is the Right Tool for This Problem</a:t>
+            </a:r>
+          </a:p>
+        </p:txBody>
+      </p:sp>
+      <p:sp>
+        <p:nvSpPr>
+          <p:cNvPr id="5" name="TextBox 4"/>
+          <p:cNvSpPr txBox="1"/>
+          <p:nvPr/>
+        </p:nvSpPr>
+        <p:spPr>
+          <a:xfrm>
+            <a:off x="457200" y="1097280"/>
+            <a:ext cx="11247120" cy="457200"/>
+          </a:xfrm>
+          <a:prstGeom prst="rect">
+            <a:avLst/>
+          </a:prstGeom>
+          <a:noFill/>
+        </p:spPr>
+        <p:txBody>
+          <a:bodyPr wrap="square">
+            <a:spAutoFit/>
+          </a:bodyPr>
+          <a:lstStyle/>
+          <a:p>
+            <a:pPr algn="ctr"/>
+            <a:r>
+              <a:rPr sz="1500" b="0">
+                <a:solidFill>
+                  <a:srgbClr val="93C5FD"/>
+                </a:solidFill>
+              </a:rPr>
+              <a:t>AI is not the point. Impact is. AI is the only tool fast enough and scalable enough to make this work.</a:t>
+            </a:r>
+          </a:p>
+        </p:txBody>
+      </p:sp>
+      <p:sp>
+        <p:nvSpPr>
+          <p:cNvPr id="6" name="Rectangle 5"/>
           <p:cNvSpPr/>
           <p:nvPr/>
         </p:nvSpPr>
         <p:spPr>
           <a:xfrm>
-            <a:off x="365760" y="1143000"/>
-            <a:ext cx="11430000" cy="1005840"/>
+            <a:off x="274320" y="1737360"/>
+            <a:ext cx="3657600" cy="2011680"/>
           </a:xfrm>
           <a:prstGeom prst="rect">
             <a:avLst/>
           </a:prstGeom>
           <a:solidFill>
-            <a:srgbClr val="2E1A5E"/>
+            <a:srgbClr val="1F2A3D"/>
           </a:solidFill>
           <a:ln>
             <a:noFill/>
@@ -8246,103 +8280,68 @@
       </p:sp>
       <p:sp>
         <p:nvSpPr>
-          <p:cNvPr id="6" name="TextBox 5"/>
-          <p:cNvSpPr txBox="1"/>
-          <p:nvPr/>
-        </p:nvSpPr>
-        <p:spPr>
-          <a:xfrm>
-            <a:off x="594360" y="1188720"/>
-            <a:ext cx="3657600" cy="320040"/>
-          </a:xfrm>
-          <a:prstGeom prst="rect">
-            <a:avLst/>
-          </a:prstGeom>
-          <a:noFill/>
-        </p:spPr>
-        <p:txBody>
-          <a:bodyPr wrap="square">
-            <a:spAutoFit/>
-          </a:bodyPr>
-          <a:lstStyle/>
-          <a:p>
-            <a:pPr algn="l"/>
-            <a:r>
-              <a:rPr sz="1200" b="1">
-                <a:solidFill>
-                  <a:srgbClr val="C4B5FD"/>
-                </a:solidFill>
-              </a:rPr>
-              <a:t>Research Question:</a:t>
-            </a:r>
-          </a:p>
-        </p:txBody>
-      </p:sp>
-      <p:sp>
-        <p:nvSpPr>
           <p:cNvPr id="7" name="TextBox 6"/>
           <p:cNvSpPr txBox="1"/>
           <p:nvPr/>
         </p:nvSpPr>
         <p:spPr>
           <a:xfrm>
-            <a:off x="594360" y="1508760"/>
-            <a:ext cx="10972800" cy="548640"/>
-          </a:xfrm>
-          <a:prstGeom prst="rect">
-            <a:avLst/>
-          </a:prstGeom>
-          <a:noFill/>
-        </p:spPr>
-        <p:txBody>
-          <a:bodyPr wrap="square">
-            <a:spAutoFit/>
-          </a:bodyPr>
-          <a:lstStyle/>
-          <a:p>
-            <a:pPr algn="l"/>
-            <a:r>
-              <a:rPr sz="1500" b="0">
+            <a:off x="411479" y="1847088"/>
+            <a:ext cx="731520" cy="502920"/>
+          </a:xfrm>
+          <a:prstGeom prst="rect">
+            <a:avLst/>
+          </a:prstGeom>
+          <a:noFill/>
+        </p:spPr>
+        <p:txBody>
+          <a:bodyPr wrap="square">
+            <a:spAutoFit/>
+          </a:bodyPr>
+          <a:lstStyle/>
+          <a:p>
+            <a:pPr algn="l"/>
+            <a:r>
+              <a:rPr sz="2200" b="0">
+                <a:solidFill>
+                  <a:srgbClr val="111827"/>
+                </a:solidFill>
+              </a:rPr>
+              <a:t>🌍</a:t>
+            </a:r>
+          </a:p>
+        </p:txBody>
+      </p:sp>
+      <p:sp>
+        <p:nvSpPr>
+          <p:cNvPr id="8" name="TextBox 7"/>
+          <p:cNvSpPr txBox="1"/>
+          <p:nvPr/>
+        </p:nvSpPr>
+        <p:spPr>
+          <a:xfrm>
+            <a:off x="411479" y="2331720"/>
+            <a:ext cx="3383280" cy="365760"/>
+          </a:xfrm>
+          <a:prstGeom prst="rect">
+            <a:avLst/>
+          </a:prstGeom>
+          <a:noFill/>
+        </p:spPr>
+        <p:txBody>
+          <a:bodyPr wrap="square">
+            <a:spAutoFit/>
+          </a:bodyPr>
+          <a:lstStyle/>
+          <a:p>
+            <a:pPr algn="l"/>
+            <a:r>
+              <a:rPr sz="1400" b="1">
                 <a:solidFill>
                   <a:srgbClr val="FFFFFF"/>
                 </a:solidFill>
               </a:rPr>
-              <a:t>"Do LLMs exhibit higher rates of confident-but-wrong verdicts on politically
-charged health claims compared to politically neutral ones?"</a:t>
-            </a:r>
-          </a:p>
-        </p:txBody>
-      </p:sp>
-      <p:sp>
-        <p:nvSpPr>
-          <p:cNvPr id="8" name="TextBox 7"/>
-          <p:cNvSpPr txBox="1"/>
-          <p:nvPr/>
-        </p:nvSpPr>
-        <p:spPr>
-          <a:xfrm>
-            <a:off x="365760" y="2331720"/>
-            <a:ext cx="5303520" cy="365760"/>
-          </a:xfrm>
-          <a:prstGeom prst="rect">
-            <a:avLst/>
-          </a:prstGeom>
-          <a:noFill/>
-        </p:spPr>
-        <p:txBody>
-          <a:bodyPr wrap="square">
-            <a:spAutoFit/>
-          </a:bodyPr>
-          <a:lstStyle/>
-          <a:p>
-            <a:pPr algn="l"/>
-            <a:r>
-              <a:rPr sz="1600" b="1">
-                <a:solidFill>
-                  <a:srgbClr val="7916F6"/>
-                </a:solidFill>
-              </a:rPr>
-              <a:t>Why It Matters</a:t>
+              <a:t>Scale</a:t>
             </a:r>
           </a:p>
         </p:txBody>
@@ -8355,150 +8354,48 @@
         </p:nvSpPr>
         <p:spPr>
           <a:xfrm>
-            <a:off x="365760" y="2788920"/>
-            <a:ext cx="5486400" cy="502920"/>
-          </a:xfrm>
-          <a:prstGeom prst="rect">
-            <a:avLst/>
-          </a:prstGeom>
-          <a:noFill/>
-        </p:spPr>
-        <p:txBody>
-          <a:bodyPr wrap="square">
-            <a:spAutoFit/>
-          </a:bodyPr>
-          <a:lstStyle/>
-          <a:p>
-            <a:pPr algn="l"/>
-            <a:r>
-              <a:rPr sz="1200" b="0">
-                <a:solidFill>
-                  <a:srgbClr val="C4B5FD"/>
-                </a:solidFill>
-              </a:rPr>
-              <a:t>• AI fact-checkers are being deployed at scale by major social platforms right now</a:t>
-            </a:r>
-          </a:p>
-        </p:txBody>
-      </p:sp>
-      <p:sp>
-        <p:nvSpPr>
-          <p:cNvPr id="10" name="TextBox 9"/>
-          <p:cNvSpPr txBox="1"/>
-          <p:nvPr/>
-        </p:nvSpPr>
-        <p:spPr>
-          <a:xfrm>
-            <a:off x="365760" y="3383279"/>
-            <a:ext cx="5486400" cy="502920"/>
-          </a:xfrm>
-          <a:prstGeom prst="rect">
-            <a:avLst/>
-          </a:prstGeom>
-          <a:noFill/>
-        </p:spPr>
-        <p:txBody>
-          <a:bodyPr wrap="square">
-            <a:spAutoFit/>
-          </a:bodyPr>
-          <a:lstStyle/>
-          <a:p>
-            <a:pPr algn="l"/>
-            <a:r>
-              <a:rPr sz="1200" b="0">
-                <a:solidFill>
-                  <a:srgbClr val="C4B5FD"/>
-                </a:solidFill>
-              </a:rPr>
-              <a:t>• If they're systematically wrong on politically charged topics, they may amplify misinformation</a:t>
-            </a:r>
-          </a:p>
-        </p:txBody>
-      </p:sp>
-      <p:sp>
-        <p:nvSpPr>
-          <p:cNvPr id="11" name="TextBox 10"/>
-          <p:cNvSpPr txBox="1"/>
-          <p:nvPr/>
-        </p:nvSpPr>
-        <p:spPr>
-          <a:xfrm>
-            <a:off x="365760" y="3977639"/>
-            <a:ext cx="5486400" cy="502920"/>
-          </a:xfrm>
-          <a:prstGeom prst="rect">
-            <a:avLst/>
-          </a:prstGeom>
-          <a:noFill/>
-        </p:spPr>
-        <p:txBody>
-          <a:bodyPr wrap="square">
-            <a:spAutoFit/>
-          </a:bodyPr>
-          <a:lstStyle/>
-          <a:p>
-            <a:pPr algn="l"/>
-            <a:r>
-              <a:rPr sz="1200" b="0">
-                <a:solidFill>
-                  <a:srgbClr val="C4B5FD"/>
-                </a:solidFill>
-              </a:rPr>
-              <a:t>• Nobody has measured this specifically for health claims — this is original research</a:t>
-            </a:r>
-          </a:p>
-        </p:txBody>
-      </p:sp>
-      <p:sp>
-        <p:nvSpPr>
-          <p:cNvPr id="12" name="TextBox 11"/>
-          <p:cNvSpPr txBox="1"/>
-          <p:nvPr/>
-        </p:nvSpPr>
-        <p:spPr>
-          <a:xfrm>
-            <a:off x="6400800" y="2331720"/>
-            <a:ext cx="5303520" cy="365760"/>
-          </a:xfrm>
-          <a:prstGeom prst="rect">
-            <a:avLst/>
-          </a:prstGeom>
-          <a:noFill/>
-        </p:spPr>
-        <p:txBody>
-          <a:bodyPr wrap="square">
-            <a:spAutoFit/>
-          </a:bodyPr>
-          <a:lstStyle/>
-          <a:p>
-            <a:pPr algn="l"/>
-            <a:r>
-              <a:rPr sz="1600" b="1">
-                <a:solidFill>
-                  <a:srgbClr val="7916F6"/>
-                </a:solidFill>
-              </a:rPr>
-              <a:t>Research Plan</a:t>
-            </a:r>
-          </a:p>
-        </p:txBody>
-      </p:sp>
-      <p:sp>
-        <p:nvSpPr>
-          <p:cNvPr id="13" name="Rectangle 12"/>
+            <a:off x="411479" y="2743200"/>
+            <a:ext cx="3383280" cy="914400"/>
+          </a:xfrm>
+          <a:prstGeom prst="rect">
+            <a:avLst/>
+          </a:prstGeom>
+          <a:noFill/>
+        </p:spPr>
+        <p:txBody>
+          <a:bodyPr wrap="square">
+            <a:spAutoFit/>
+          </a:bodyPr>
+          <a:lstStyle/>
+          <a:p>
+            <a:pPr algn="l"/>
+            <a:r>
+              <a:rPr sz="1100" b="0">
+                <a:solidFill>
+                  <a:srgbClr val="6B7280"/>
+                </a:solidFill>
+              </a:rPr>
+              <a:t>Millions of new health claims are posted daily. Human fact-checkers can't keep up. AI never sleeps and scales to any volume.</a:t>
+            </a:r>
+          </a:p>
+        </p:txBody>
+      </p:sp>
+      <p:sp>
+        <p:nvSpPr>
+          <p:cNvPr id="10" name="Rectangle 9"/>
           <p:cNvSpPr/>
           <p:nvPr/>
         </p:nvSpPr>
         <p:spPr>
           <a:xfrm>
-            <a:off x="6400800" y="2788920"/>
-            <a:ext cx="2651760" cy="1097280"/>
+            <a:off x="4114800" y="1737360"/>
+            <a:ext cx="3657600" cy="2011680"/>
           </a:xfrm>
           <a:prstGeom prst="rect">
             <a:avLst/>
           </a:prstGeom>
           <a:solidFill>
-            <a:srgbClr val="2E1A5E"/>
+            <a:srgbClr val="1F2A3D"/>
           </a:solidFill>
           <a:ln>
             <a:noFill/>
@@ -8528,48 +8425,82 @@
       </p:sp>
       <p:sp>
         <p:nvSpPr>
-          <p:cNvPr id="14" name="TextBox 13"/>
-          <p:cNvSpPr txBox="1"/>
-          <p:nvPr/>
-        </p:nvSpPr>
-        <p:spPr>
-          <a:xfrm>
-            <a:off x="6492240" y="2834639"/>
-            <a:ext cx="822960" cy="548640"/>
-          </a:xfrm>
-          <a:prstGeom prst="rect">
-            <a:avLst/>
-          </a:prstGeom>
-          <a:noFill/>
-        </p:spPr>
-        <p:txBody>
-          <a:bodyPr wrap="square">
-            <a:spAutoFit/>
-          </a:bodyPr>
-          <a:lstStyle/>
-          <a:p>
-            <a:pPr algn="ctr"/>
-            <a:r>
-              <a:rPr sz="2800" b="1">
-                <a:solidFill>
-                  <a:srgbClr val="7916F6"/>
-                </a:solidFill>
-              </a:rPr>
-              <a:t>150</a:t>
-            </a:r>
-          </a:p>
-        </p:txBody>
-      </p:sp>
-      <p:sp>
-        <p:nvSpPr>
-          <p:cNvPr id="15" name="TextBox 14"/>
-          <p:cNvSpPr txBox="1"/>
-          <p:nvPr/>
-        </p:nvSpPr>
-        <p:spPr>
-          <a:xfrm>
-            <a:off x="6492240" y="3337560"/>
-            <a:ext cx="2468880" cy="502920"/>
+          <p:cNvPr id="11" name="TextBox 10"/>
+          <p:cNvSpPr txBox="1"/>
+          <p:nvPr/>
+        </p:nvSpPr>
+        <p:spPr>
+          <a:xfrm>
+            <a:off x="4251960" y="1847088"/>
+            <a:ext cx="731520" cy="502920"/>
+          </a:xfrm>
+          <a:prstGeom prst="rect">
+            <a:avLst/>
+          </a:prstGeom>
+          <a:noFill/>
+        </p:spPr>
+        <p:txBody>
+          <a:bodyPr wrap="square">
+            <a:spAutoFit/>
+          </a:bodyPr>
+          <a:lstStyle/>
+          <a:p>
+            <a:pPr algn="l"/>
+            <a:r>
+              <a:rPr sz="2200" b="0">
+                <a:solidFill>
+                  <a:srgbClr val="111827"/>
+                </a:solidFill>
+              </a:rPr>
+              <a:t>🧩</a:t>
+            </a:r>
+          </a:p>
+        </p:txBody>
+      </p:sp>
+      <p:sp>
+        <p:nvSpPr>
+          <p:cNvPr id="12" name="TextBox 11"/>
+          <p:cNvSpPr txBox="1"/>
+          <p:nvPr/>
+        </p:nvSpPr>
+        <p:spPr>
+          <a:xfrm>
+            <a:off x="4251960" y="2331720"/>
+            <a:ext cx="3383280" cy="365760"/>
+          </a:xfrm>
+          <a:prstGeom prst="rect">
+            <a:avLst/>
+          </a:prstGeom>
+          <a:noFill/>
+        </p:spPr>
+        <p:txBody>
+          <a:bodyPr wrap="square">
+            <a:spAutoFit/>
+          </a:bodyPr>
+          <a:lstStyle/>
+          <a:p>
+            <a:pPr algn="l"/>
+            <a:r>
+              <a:rPr sz="1400" b="1">
+                <a:solidFill>
+                  <a:srgbClr val="FFFFFF"/>
+                </a:solidFill>
+              </a:rPr>
+              <a:t>Decomposition</a:t>
+            </a:r>
+          </a:p>
+        </p:txBody>
+      </p:sp>
+      <p:sp>
+        <p:nvSpPr>
+          <p:cNvPr id="13" name="TextBox 12"/>
+          <p:cNvSpPr txBox="1"/>
+          <p:nvPr/>
+        </p:nvSpPr>
+        <p:spPr>
+          <a:xfrm>
+            <a:off x="4251960" y="2743200"/>
+            <a:ext cx="3383280" cy="914400"/>
           </a:xfrm>
           <a:prstGeom prst="rect">
             <a:avLst/>
@@ -8586,31 +8517,30 @@
             <a:r>
               <a:rPr sz="1100" b="0">
                 <a:solidFill>
-                  <a:srgbClr val="C4B5FD"/>
-                </a:solidFill>
-              </a:rPr>
-              <a:t>labeled health claims
-(neutral + politically charged)</a:t>
-            </a:r>
-          </a:p>
-        </p:txBody>
-      </p:sp>
-      <p:sp>
-        <p:nvSpPr>
-          <p:cNvPr id="16" name="Rectangle 15"/>
+                  <a:srgbClr val="6B7280"/>
+                </a:solidFill>
+              </a:rPr>
+              <a:t>AI can break compound claims into individual assertions automatically — "vaccines cause autism AND damage immunity" is two claims, not one.</a:t>
+            </a:r>
+          </a:p>
+        </p:txBody>
+      </p:sp>
+      <p:sp>
+        <p:nvSpPr>
+          <p:cNvPr id="14" name="Rectangle 13"/>
           <p:cNvSpPr/>
           <p:nvPr/>
         </p:nvSpPr>
         <p:spPr>
           <a:xfrm>
-            <a:off x="9235440" y="2788920"/>
-            <a:ext cx="2651760" cy="1097280"/>
+            <a:off x="7955280" y="1737360"/>
+            <a:ext cx="3657600" cy="2011680"/>
           </a:xfrm>
           <a:prstGeom prst="rect">
             <a:avLst/>
           </a:prstGeom>
           <a:solidFill>
-            <a:srgbClr val="2E1A5E"/>
+            <a:srgbClr val="1F2A3D"/>
           </a:solidFill>
           <a:ln>
             <a:noFill/>
@@ -8640,48 +8570,82 @@
       </p:sp>
       <p:sp>
         <p:nvSpPr>
+          <p:cNvPr id="15" name="TextBox 14"/>
+          <p:cNvSpPr txBox="1"/>
+          <p:nvPr/>
+        </p:nvSpPr>
+        <p:spPr>
+          <a:xfrm>
+            <a:off x="8092440" y="1847088"/>
+            <a:ext cx="731520" cy="502920"/>
+          </a:xfrm>
+          <a:prstGeom prst="rect">
+            <a:avLst/>
+          </a:prstGeom>
+          <a:noFill/>
+        </p:spPr>
+        <p:txBody>
+          <a:bodyPr wrap="square">
+            <a:spAutoFit/>
+          </a:bodyPr>
+          <a:lstStyle/>
+          <a:p>
+            <a:pPr algn="l"/>
+            <a:r>
+              <a:rPr sz="2200" b="0">
+                <a:solidFill>
+                  <a:srgbClr val="111827"/>
+                </a:solidFill>
+              </a:rPr>
+              <a:t>⚖️</a:t>
+            </a:r>
+          </a:p>
+        </p:txBody>
+      </p:sp>
+      <p:sp>
+        <p:nvSpPr>
+          <p:cNvPr id="16" name="TextBox 15"/>
+          <p:cNvSpPr txBox="1"/>
+          <p:nvPr/>
+        </p:nvSpPr>
+        <p:spPr>
+          <a:xfrm>
+            <a:off x="8092440" y="2331720"/>
+            <a:ext cx="3383280" cy="365760"/>
+          </a:xfrm>
+          <a:prstGeom prst="rect">
+            <a:avLst/>
+          </a:prstGeom>
+          <a:noFill/>
+        </p:spPr>
+        <p:txBody>
+          <a:bodyPr wrap="square">
+            <a:spAutoFit/>
+          </a:bodyPr>
+          <a:lstStyle/>
+          <a:p>
+            <a:pPr algn="l"/>
+            <a:r>
+              <a:rPr sz="1400" b="1">
+                <a:solidFill>
+                  <a:srgbClr val="FFFFFF"/>
+                </a:solidFill>
+              </a:rPr>
+              <a:t>Calibrated Uncertainty</a:t>
+            </a:r>
+          </a:p>
+        </p:txBody>
+      </p:sp>
+      <p:sp>
+        <p:nvSpPr>
           <p:cNvPr id="17" name="TextBox 16"/>
           <p:cNvSpPr txBox="1"/>
           <p:nvPr/>
         </p:nvSpPr>
         <p:spPr>
           <a:xfrm>
-            <a:off x="9326880" y="2834639"/>
-            <a:ext cx="822960" cy="548640"/>
-          </a:xfrm>
-          <a:prstGeom prst="rect">
-            <a:avLst/>
-          </a:prstGeom>
-          <a:noFill/>
-        </p:spPr>
-        <p:txBody>
-          <a:bodyPr wrap="square">
-            <a:spAutoFit/>
-          </a:bodyPr>
-          <a:lstStyle/>
-          <a:p>
-            <a:pPr algn="ctr"/>
-            <a:r>
-              <a:rPr sz="2800" b="1">
-                <a:solidFill>
-                  <a:srgbClr val="7916F6"/>
-                </a:solidFill>
-              </a:rPr>
-              <a:t>3</a:t>
-            </a:r>
-          </a:p>
-        </p:txBody>
-      </p:sp>
-      <p:sp>
-        <p:nvSpPr>
-          <p:cNvPr id="18" name="TextBox 17"/>
-          <p:cNvSpPr txBox="1"/>
-          <p:nvPr/>
-        </p:nvSpPr>
-        <p:spPr>
-          <a:xfrm>
-            <a:off x="9326880" y="3337560"/>
-            <a:ext cx="2468880" cy="502920"/>
+            <a:off x="8092440" y="2743200"/>
+            <a:ext cx="3383280" cy="914400"/>
           </a:xfrm>
           <a:prstGeom prst="rect">
             <a:avLst/>
@@ -8698,31 +8662,30 @@
             <a:r>
               <a:rPr sz="1100" b="0">
                 <a:solidFill>
-                  <a:srgbClr val="C4B5FD"/>
-                </a:solidFill>
-              </a:rPr>
-              <a:t>AI models tested
-(Claude · GPT-4 · Llama)</a:t>
-            </a:r>
-          </a:p>
-        </p:txBody>
-      </p:sp>
-      <p:sp>
-        <p:nvSpPr>
-          <p:cNvPr id="19" name="Rectangle 18"/>
+                  <a:srgbClr val="6B7280"/>
+                </a:solidFill>
+              </a:rPr>
+              <a:t>AI can express degrees of confidence — not just true/false. A tool that says "I'm not sure" is more trustworthy than one that's always confident.</a:t>
+            </a:r>
+          </a:p>
+        </p:txBody>
+      </p:sp>
+      <p:sp>
+        <p:nvSpPr>
+          <p:cNvPr id="18" name="Rectangle 17"/>
           <p:cNvSpPr/>
           <p:nvPr/>
         </p:nvSpPr>
         <p:spPr>
           <a:xfrm>
-            <a:off x="6400800" y="4023360"/>
-            <a:ext cx="2651760" cy="1097280"/>
+            <a:off x="274320" y="3977639"/>
+            <a:ext cx="5486400" cy="2011680"/>
           </a:xfrm>
           <a:prstGeom prst="rect">
             <a:avLst/>
           </a:prstGeom>
           <a:solidFill>
-            <a:srgbClr val="2E1A5E"/>
+            <a:srgbClr val="1F2A3D"/>
           </a:solidFill>
           <a:ln>
             <a:noFill/>
@@ -8752,34 +8715,68 @@
       </p:sp>
       <p:sp>
         <p:nvSpPr>
+          <p:cNvPr id="19" name="TextBox 18"/>
+          <p:cNvSpPr txBox="1"/>
+          <p:nvPr/>
+        </p:nvSpPr>
+        <p:spPr>
+          <a:xfrm>
+            <a:off x="411479" y="4087368"/>
+            <a:ext cx="731520" cy="502920"/>
+          </a:xfrm>
+          <a:prstGeom prst="rect">
+            <a:avLst/>
+          </a:prstGeom>
+          <a:noFill/>
+        </p:spPr>
+        <p:txBody>
+          <a:bodyPr wrap="square">
+            <a:spAutoFit/>
+          </a:bodyPr>
+          <a:lstStyle/>
+          <a:p>
+            <a:pPr algn="l"/>
+            <a:r>
+              <a:rPr sz="2200" b="0">
+                <a:solidFill>
+                  <a:srgbClr val="111827"/>
+                </a:solidFill>
+              </a:rPr>
+              <a:t>📚</a:t>
+            </a:r>
+          </a:p>
+        </p:txBody>
+      </p:sp>
+      <p:sp>
+        <p:nvSpPr>
           <p:cNvPr id="20" name="TextBox 19"/>
           <p:cNvSpPr txBox="1"/>
           <p:nvPr/>
         </p:nvSpPr>
         <p:spPr>
           <a:xfrm>
-            <a:off x="6492240" y="4069080"/>
-            <a:ext cx="822960" cy="548640"/>
-          </a:xfrm>
-          <a:prstGeom prst="rect">
-            <a:avLst/>
-          </a:prstGeom>
-          <a:noFill/>
-        </p:spPr>
-        <p:txBody>
-          <a:bodyPr wrap="square">
-            <a:spAutoFit/>
-          </a:bodyPr>
-          <a:lstStyle/>
-          <a:p>
-            <a:pPr algn="ctr"/>
-            <a:r>
-              <a:rPr sz="2800" b="1">
-                <a:solidFill>
-                  <a:srgbClr val="7916F6"/>
-                </a:solidFill>
-              </a:rPr>
-              <a:t>Prof</a:t>
+            <a:off x="411479" y="4572000"/>
+            <a:ext cx="5212080" cy="365760"/>
+          </a:xfrm>
+          <a:prstGeom prst="rect">
+            <a:avLst/>
+          </a:prstGeom>
+          <a:noFill/>
+        </p:spPr>
+        <p:txBody>
+          <a:bodyPr wrap="square">
+            <a:spAutoFit/>
+          </a:bodyPr>
+          <a:lstStyle/>
+          <a:p>
+            <a:pPr algn="l"/>
+            <a:r>
+              <a:rPr sz="1400" b="1">
+                <a:solidFill>
+                  <a:srgbClr val="FFFFFF"/>
+                </a:solidFill>
+              </a:rPr>
+              <a:t>Evidence Synthesis</a:t>
             </a:r>
           </a:p>
         </p:txBody>
@@ -8792,8 +8789,8 @@
         </p:nvSpPr>
         <p:spPr>
           <a:xfrm>
-            <a:off x="6492240" y="4572000"/>
-            <a:ext cx="2468880" cy="502920"/>
+            <a:off x="411479" y="4983479"/>
+            <a:ext cx="5212080" cy="914400"/>
           </a:xfrm>
           <a:prstGeom prst="rect">
             <a:avLst/>
@@ -8810,11 +8807,10 @@
             <a:r>
               <a:rPr sz="1100" b="0">
                 <a:solidFill>
-                  <a:srgbClr val="C4B5FD"/>
-                </a:solidFill>
-              </a:rPr>
-              <a:t>mentor collaborating
-on methodology</a:t>
+                  <a:srgbClr val="6B7280"/>
+                </a:solidFill>
+              </a:rPr>
+              <a:t>Cross-references CDC, WHO, NIH, and PubMed simultaneously in seconds — a task that takes a human 20+ minutes.</a:t>
             </a:r>
           </a:p>
         </p:txBody>
@@ -8827,14 +8823,14 @@
         </p:nvSpPr>
         <p:spPr>
           <a:xfrm>
-            <a:off x="9235440" y="4023360"/>
-            <a:ext cx="2651760" cy="1097280"/>
+            <a:off x="6080759" y="3977639"/>
+            <a:ext cx="5486400" cy="2011680"/>
           </a:xfrm>
           <a:prstGeom prst="rect">
             <a:avLst/>
           </a:prstGeom>
           <a:solidFill>
-            <a:srgbClr val="2E1A5E"/>
+            <a:srgbClr val="1F2A3D"/>
           </a:solidFill>
           <a:ln>
             <a:noFill/>
@@ -8870,28 +8866,28 @@
         </p:nvSpPr>
         <p:spPr>
           <a:xfrm>
-            <a:off x="9326880" y="4069080"/>
-            <a:ext cx="822960" cy="548640"/>
-          </a:xfrm>
-          <a:prstGeom prst="rect">
-            <a:avLst/>
-          </a:prstGeom>
-          <a:noFill/>
-        </p:spPr>
-        <p:txBody>
-          <a:bodyPr wrap="square">
-            <a:spAutoFit/>
-          </a:bodyPr>
-          <a:lstStyle/>
-          <a:p>
-            <a:pPr algn="ctr"/>
-            <a:r>
-              <a:rPr sz="2800" b="1">
-                <a:solidFill>
-                  <a:srgbClr val="7916F6"/>
-                </a:solidFill>
-              </a:rPr>
-              <a:t>JEI</a:t>
+            <a:off x="6217920" y="4087368"/>
+            <a:ext cx="731520" cy="502920"/>
+          </a:xfrm>
+          <a:prstGeom prst="rect">
+            <a:avLst/>
+          </a:prstGeom>
+          <a:noFill/>
+        </p:spPr>
+        <p:txBody>
+          <a:bodyPr wrap="square">
+            <a:spAutoFit/>
+          </a:bodyPr>
+          <a:lstStyle/>
+          <a:p>
+            <a:pPr algn="l"/>
+            <a:r>
+              <a:rPr sz="2200" b="0">
+                <a:solidFill>
+                  <a:srgbClr val="111827"/>
+                </a:solidFill>
+              </a:rPr>
+              <a:t>🔓</a:t>
             </a:r>
           </a:p>
         </p:txBody>
@@ -8904,8 +8900,42 @@
         </p:nvSpPr>
         <p:spPr>
           <a:xfrm>
-            <a:off x="9326880" y="4572000"/>
-            <a:ext cx="2468880" cy="502920"/>
+            <a:off x="6217920" y="4572000"/>
+            <a:ext cx="5212080" cy="365760"/>
+          </a:xfrm>
+          <a:prstGeom prst="rect">
+            <a:avLst/>
+          </a:prstGeom>
+          <a:noFill/>
+        </p:spPr>
+        <p:txBody>
+          <a:bodyPr wrap="square">
+            <a:spAutoFit/>
+          </a:bodyPr>
+          <a:lstStyle/>
+          <a:p>
+            <a:pPr algn="l"/>
+            <a:r>
+              <a:rPr sz="1400" b="1">
+                <a:solidFill>
+                  <a:srgbClr val="FFFFFF"/>
+                </a:solidFill>
+              </a:rPr>
+              <a:t>Accessibility</a:t>
+            </a:r>
+          </a:p>
+        </p:txBody>
+      </p:sp>
+      <p:sp>
+        <p:nvSpPr>
+          <p:cNvPr id="25" name="TextBox 24"/>
+          <p:cNvSpPr txBox="1"/>
+          <p:nvPr/>
+        </p:nvSpPr>
+        <p:spPr>
+          <a:xfrm>
+            <a:off x="6217920" y="4983479"/>
+            <a:ext cx="5212080" cy="914400"/>
           </a:xfrm>
           <a:prstGeom prst="rect">
             <a:avLst/>
@@ -8922,31 +8952,30 @@
             <a:r>
               <a:rPr sz="1100" b="0">
                 <a:solidFill>
-                  <a:srgbClr val="C4B5FD"/>
-                </a:solidFill>
-              </a:rPr>
-              <a:t>target publication
-(Journal of Emerging Investigators)</a:t>
-            </a:r>
-          </a:p>
-        </p:txBody>
-      </p:sp>
-      <p:sp>
-        <p:nvSpPr>
-          <p:cNvPr id="25" name="Rectangle 24"/>
+                  <a:srgbClr val="6B7280"/>
+                </a:solidFill>
+              </a:rPr>
+              <a:t>No medical background required. Anyone can use it. Free. Works in any browser. Zero installation.</a:t>
+            </a:r>
+          </a:p>
+        </p:txBody>
+      </p:sp>
+      <p:sp>
+        <p:nvSpPr>
+          <p:cNvPr id="26" name="Rectangle 25"/>
           <p:cNvSpPr/>
           <p:nvPr/>
         </p:nvSpPr>
         <p:spPr>
           <a:xfrm>
-            <a:off x="365760" y="6080760"/>
-            <a:ext cx="11430000" cy="685800"/>
+            <a:off x="274320" y="6217920"/>
+            <a:ext cx="11612880" cy="502920"/>
           </a:xfrm>
           <a:prstGeom prst="rect">
             <a:avLst/>
           </a:prstGeom>
           <a:solidFill>
-            <a:srgbClr val="1E0A40"/>
+            <a:srgbClr val="1E3A8A"/>
           </a:solidFill>
           <a:ln>
             <a:noFill/>
@@ -8976,34 +9005,34 @@
       </p:sp>
       <p:sp>
         <p:nvSpPr>
-          <p:cNvPr id="26" name="TextBox 25"/>
-          <p:cNvSpPr txBox="1"/>
-          <p:nvPr/>
-        </p:nvSpPr>
-        <p:spPr>
-          <a:xfrm>
-            <a:off x="594360" y="6144768"/>
-            <a:ext cx="10972800" cy="548640"/>
-          </a:xfrm>
-          <a:prstGeom prst="rect">
-            <a:avLst/>
-          </a:prstGeom>
-          <a:noFill/>
-        </p:spPr>
-        <p:txBody>
-          <a:bodyPr wrap="square">
-            <a:spAutoFit/>
-          </a:bodyPr>
-          <a:lstStyle/>
-          <a:p>
-            <a:pPr algn="l"/>
+          <p:cNvPr id="27" name="TextBox 26"/>
+          <p:cNvSpPr txBox="1"/>
+          <p:nvPr/>
+        </p:nvSpPr>
+        <p:spPr>
+          <a:xfrm>
+            <a:off x="457200" y="6263640"/>
+            <a:ext cx="11247120" cy="411480"/>
+          </a:xfrm>
+          <a:prstGeom prst="rect">
+            <a:avLst/>
+          </a:prstGeom>
+          <a:noFill/>
+        </p:spPr>
+        <p:txBody>
+          <a:bodyPr wrap="square">
+            <a:spAutoFit/>
+          </a:bodyPr>
+          <a:lstStyle/>
+          <a:p>
+            <a:pPr algn="ctr"/>
             <a:r>
               <a:rPr sz="1200" b="0">
                 <a:solidFill>
-                  <a:srgbClr val="C4B5FD"/>
-                </a:solidFill>
-              </a:rPr>
-              <a:t>⚡  The Political Charge Flag in MedCheck is the user-facing expression of this research question — it tells users when AI reliability may be lower and marks claims for our dataset.</a:t>
+                  <a:srgbClr val="FFFFFF"/>
+                </a:solidFill>
+              </a:rPr>
+              <a:t>💡  Key insight: The cognitive task of fact-checking — finding evidence, weighing it, synthesizing a verdict — is exactly what LLMs are trained to do. MedCheck harnesses that for public health.</a:t>
             </a:r>
           </a:p>
         </p:txBody>

</xml_diff>

<commit_message>
PPTX: add URL footer to all slides, cleaned up make_slides.py
</commit_message>
<xml_diff>
--- a/MedCheck_ACP_2026.pptx
+++ b/MedCheck_ACP_2026.pptx
@@ -3473,6 +3473,40 @@
           </a:p>
         </p:txBody>
       </p:sp>
+      <p:sp>
+        <p:nvSpPr>
+          <p:cNvPr id="12" name="TextBox 11"/>
+          <p:cNvSpPr txBox="1"/>
+          <p:nvPr/>
+        </p:nvSpPr>
+        <p:spPr>
+          <a:xfrm>
+            <a:off x="274320" y="6537960"/>
+            <a:ext cx="11612880" cy="256032"/>
+          </a:xfrm>
+          <a:prstGeom prst="rect">
+            <a:avLst/>
+          </a:prstGeom>
+          <a:noFill/>
+        </p:spPr>
+        <p:txBody>
+          <a:bodyPr wrap="none">
+            <a:spAutoFit/>
+          </a:bodyPr>
+          <a:lstStyle/>
+          <a:p>
+            <a:pPr algn="r"/>
+            <a:r>
+              <a:rPr sz="900">
+                <a:solidFill>
+                  <a:srgbClr val="9CA3AF"/>
+                </a:solidFill>
+              </a:rPr>
+              <a:t>medcheck-murex.vercel.app</a:t>
+            </a:r>
+          </a:p>
+        </p:txBody>
+      </p:sp>
     </p:spTree>
   </p:cSld>
   <p:clrMapOvr>
@@ -4080,6 +4114,40 @@
           </a:p>
         </p:txBody>
       </p:sp>
+      <p:sp>
+        <p:nvSpPr>
+          <p:cNvPr id="18" name="TextBox 17"/>
+          <p:cNvSpPr txBox="1"/>
+          <p:nvPr/>
+        </p:nvSpPr>
+        <p:spPr>
+          <a:xfrm>
+            <a:off x="274320" y="6537960"/>
+            <a:ext cx="11612880" cy="256032"/>
+          </a:xfrm>
+          <a:prstGeom prst="rect">
+            <a:avLst/>
+          </a:prstGeom>
+          <a:noFill/>
+        </p:spPr>
+        <p:txBody>
+          <a:bodyPr wrap="none">
+            <a:spAutoFit/>
+          </a:bodyPr>
+          <a:lstStyle/>
+          <a:p>
+            <a:pPr algn="r"/>
+            <a:r>
+              <a:rPr sz="900">
+                <a:solidFill>
+                  <a:srgbClr val="9CA3AF"/>
+                </a:solidFill>
+              </a:rPr>
+              <a:t>medcheck-murex.vercel.app</a:t>
+            </a:r>
+          </a:p>
+        </p:txBody>
+      </p:sp>
     </p:spTree>
   </p:cSld>
   <p:clrMapOvr>
@@ -4897,6 +4965,40 @@
           </a:p>
         </p:txBody>
       </p:sp>
+      <p:sp>
+        <p:nvSpPr>
+          <p:cNvPr id="23" name="TextBox 22"/>
+          <p:cNvSpPr txBox="1"/>
+          <p:nvPr/>
+        </p:nvSpPr>
+        <p:spPr>
+          <a:xfrm>
+            <a:off x="274320" y="6537960"/>
+            <a:ext cx="11612880" cy="256032"/>
+          </a:xfrm>
+          <a:prstGeom prst="rect">
+            <a:avLst/>
+          </a:prstGeom>
+          <a:noFill/>
+        </p:spPr>
+        <p:txBody>
+          <a:bodyPr wrap="none">
+            <a:spAutoFit/>
+          </a:bodyPr>
+          <a:lstStyle/>
+          <a:p>
+            <a:pPr algn="r"/>
+            <a:r>
+              <a:rPr sz="900">
+                <a:solidFill>
+                  <a:srgbClr val="9CA3AF"/>
+                </a:solidFill>
+              </a:rPr>
+              <a:t>medcheck-murex.vercel.app</a:t>
+            </a:r>
+          </a:p>
+        </p:txBody>
+      </p:sp>
     </p:spTree>
   </p:cSld>
   <p:clrMapOvr>
@@ -5957,6 +6059,40 @@
           </a:p>
         </p:txBody>
       </p:sp>
+      <p:sp>
+        <p:nvSpPr>
+          <p:cNvPr id="30" name="TextBox 29"/>
+          <p:cNvSpPr txBox="1"/>
+          <p:nvPr/>
+        </p:nvSpPr>
+        <p:spPr>
+          <a:xfrm>
+            <a:off x="274320" y="6537960"/>
+            <a:ext cx="11612880" cy="256032"/>
+          </a:xfrm>
+          <a:prstGeom prst="rect">
+            <a:avLst/>
+          </a:prstGeom>
+          <a:noFill/>
+        </p:spPr>
+        <p:txBody>
+          <a:bodyPr wrap="none">
+            <a:spAutoFit/>
+          </a:bodyPr>
+          <a:lstStyle/>
+          <a:p>
+            <a:pPr algn="r"/>
+            <a:r>
+              <a:rPr sz="900">
+                <a:solidFill>
+                  <a:srgbClr val="9CA3AF"/>
+                </a:solidFill>
+              </a:rPr>
+              <a:t>medcheck-murex.vercel.app</a:t>
+            </a:r>
+          </a:p>
+        </p:txBody>
+      </p:sp>
     </p:spTree>
   </p:cSld>
   <p:clrMapOvr>
@@ -7260,6 +7396,40 @@
           </a:p>
         </p:txBody>
       </p:sp>
+      <p:sp>
+        <p:nvSpPr>
+          <p:cNvPr id="37" name="TextBox 36"/>
+          <p:cNvSpPr txBox="1"/>
+          <p:nvPr/>
+        </p:nvSpPr>
+        <p:spPr>
+          <a:xfrm>
+            <a:off x="274320" y="6537960"/>
+            <a:ext cx="11612880" cy="256032"/>
+          </a:xfrm>
+          <a:prstGeom prst="rect">
+            <a:avLst/>
+          </a:prstGeom>
+          <a:noFill/>
+        </p:spPr>
+        <p:txBody>
+          <a:bodyPr wrap="none">
+            <a:spAutoFit/>
+          </a:bodyPr>
+          <a:lstStyle/>
+          <a:p>
+            <a:pPr algn="r"/>
+            <a:r>
+              <a:rPr sz="900">
+                <a:solidFill>
+                  <a:srgbClr val="9CA3AF"/>
+                </a:solidFill>
+              </a:rPr>
+              <a:t>medcheck-murex.vercel.app</a:t>
+            </a:r>
+          </a:p>
+        </p:txBody>
+      </p:sp>
     </p:spTree>
   </p:cSld>
   <p:clrMapOvr>
@@ -8063,6 +8233,40 @@
           </a:p>
         </p:txBody>
       </p:sp>
+      <p:sp>
+        <p:nvSpPr>
+          <p:cNvPr id="23" name="TextBox 22"/>
+          <p:cNvSpPr txBox="1"/>
+          <p:nvPr/>
+        </p:nvSpPr>
+        <p:spPr>
+          <a:xfrm>
+            <a:off x="274320" y="6537960"/>
+            <a:ext cx="11612880" cy="256032"/>
+          </a:xfrm>
+          <a:prstGeom prst="rect">
+            <a:avLst/>
+          </a:prstGeom>
+          <a:noFill/>
+        </p:spPr>
+        <p:txBody>
+          <a:bodyPr wrap="none">
+            <a:spAutoFit/>
+          </a:bodyPr>
+          <a:lstStyle/>
+          <a:p>
+            <a:pPr algn="r"/>
+            <a:r>
+              <a:rPr sz="900">
+                <a:solidFill>
+                  <a:srgbClr val="9CA3AF"/>
+                </a:solidFill>
+              </a:rPr>
+              <a:t>medcheck-murex.vercel.app</a:t>
+            </a:r>
+          </a:p>
+        </p:txBody>
+      </p:sp>
     </p:spTree>
   </p:cSld>
   <p:clrMapOvr>
@@ -9037,6 +9241,40 @@
           </a:p>
         </p:txBody>
       </p:sp>
+      <p:sp>
+        <p:nvSpPr>
+          <p:cNvPr id="28" name="TextBox 27"/>
+          <p:cNvSpPr txBox="1"/>
+          <p:nvPr/>
+        </p:nvSpPr>
+        <p:spPr>
+          <a:xfrm>
+            <a:off x="274320" y="6537960"/>
+            <a:ext cx="11612880" cy="256032"/>
+          </a:xfrm>
+          <a:prstGeom prst="rect">
+            <a:avLst/>
+          </a:prstGeom>
+          <a:noFill/>
+        </p:spPr>
+        <p:txBody>
+          <a:bodyPr wrap="none">
+            <a:spAutoFit/>
+          </a:bodyPr>
+          <a:lstStyle/>
+          <a:p>
+            <a:pPr algn="r"/>
+            <a:r>
+              <a:rPr sz="900">
+                <a:solidFill>
+                  <a:srgbClr val="9CA3AF"/>
+                </a:solidFill>
+              </a:rPr>
+              <a:t>medcheck-murex.vercel.app</a:t>
+            </a:r>
+          </a:p>
+        </p:txBody>
+      </p:sp>
     </p:spTree>
   </p:cSld>
   <p:clrMapOvr>
@@ -10490,6 +10728,40 @@
           </a:p>
         </p:txBody>
       </p:sp>
+      <p:sp>
+        <p:nvSpPr>
+          <p:cNvPr id="42" name="TextBox 41"/>
+          <p:cNvSpPr txBox="1"/>
+          <p:nvPr/>
+        </p:nvSpPr>
+        <p:spPr>
+          <a:xfrm>
+            <a:off x="274320" y="6537960"/>
+            <a:ext cx="11612880" cy="256032"/>
+          </a:xfrm>
+          <a:prstGeom prst="rect">
+            <a:avLst/>
+          </a:prstGeom>
+          <a:noFill/>
+        </p:spPr>
+        <p:txBody>
+          <a:bodyPr wrap="none">
+            <a:spAutoFit/>
+          </a:bodyPr>
+          <a:lstStyle/>
+          <a:p>
+            <a:pPr algn="r"/>
+            <a:r>
+              <a:rPr sz="900">
+                <a:solidFill>
+                  <a:srgbClr val="9CA3AF"/>
+                </a:solidFill>
+              </a:rPr>
+              <a:t>medcheck-murex.vercel.app</a:t>
+            </a:r>
+          </a:p>
+        </p:txBody>
+      </p:sp>
     </p:spTree>
   </p:cSld>
   <p:clrMapOvr>
@@ -11815,6 +12087,40 @@
           </a:p>
         </p:txBody>
       </p:sp>
+      <p:sp>
+        <p:nvSpPr>
+          <p:cNvPr id="37" name="TextBox 36"/>
+          <p:cNvSpPr txBox="1"/>
+          <p:nvPr/>
+        </p:nvSpPr>
+        <p:spPr>
+          <a:xfrm>
+            <a:off x="274320" y="6537960"/>
+            <a:ext cx="11612880" cy="256032"/>
+          </a:xfrm>
+          <a:prstGeom prst="rect">
+            <a:avLst/>
+          </a:prstGeom>
+          <a:noFill/>
+        </p:spPr>
+        <p:txBody>
+          <a:bodyPr wrap="none">
+            <a:spAutoFit/>
+          </a:bodyPr>
+          <a:lstStyle/>
+          <a:p>
+            <a:pPr algn="r"/>
+            <a:r>
+              <a:rPr sz="900">
+                <a:solidFill>
+                  <a:srgbClr val="9CA3AF"/>
+                </a:solidFill>
+              </a:rPr>
+              <a:t>medcheck-murex.vercel.app</a:t>
+            </a:r>
+          </a:p>
+        </p:txBody>
+      </p:sp>
     </p:spTree>
   </p:cSld>
   <p:clrMapOvr>
@@ -13291,6 +13597,40 @@
 Free for everyone
 Media literacy curriculum
 Platform integration</a:t>
+            </a:r>
+          </a:p>
+        </p:txBody>
+      </p:sp>
+      <p:sp>
+        <p:nvSpPr>
+          <p:cNvPr id="39" name="TextBox 38"/>
+          <p:cNvSpPr txBox="1"/>
+          <p:nvPr/>
+        </p:nvSpPr>
+        <p:spPr>
+          <a:xfrm>
+            <a:off x="274320" y="6537960"/>
+            <a:ext cx="11612880" cy="256032"/>
+          </a:xfrm>
+          <a:prstGeom prst="rect">
+            <a:avLst/>
+          </a:prstGeom>
+          <a:noFill/>
+        </p:spPr>
+        <p:txBody>
+          <a:bodyPr wrap="none">
+            <a:spAutoFit/>
+          </a:bodyPr>
+          <a:lstStyle/>
+          <a:p>
+            <a:pPr algn="r"/>
+            <a:r>
+              <a:rPr sz="900">
+                <a:solidFill>
+                  <a:srgbClr val="9CA3AF"/>
+                </a:solidFill>
+              </a:rPr>
+              <a:t>medcheck-murex.vercel.app</a:t>
             </a:r>
           </a:p>
         </p:txBody>

</xml_diff>